<commit_message>
Commit all current project changes
</commit_message>
<xml_diff>
--- a/notes/New Microsoft PowerPoint Presentation.pptx
+++ b/notes/New Microsoft PowerPoint Presentation.pptx
@@ -7,6 +7,8 @@
   <p:sldIdLst>
     <p:sldId id="256" r:id="rId2"/>
     <p:sldId id="257" r:id="rId3"/>
+    <p:sldId id="258" r:id="rId4"/>
+    <p:sldId id="259" r:id="rId5"/>
   </p:sldIdLst>
   <p:sldSz cx="12192000" cy="6858000"/>
   <p:notesSz cx="6858000" cy="9144000"/>
@@ -105,15 +107,28 @@
       </a:defRPr>
     </a:lvl9pPr>
   </p:defaultTextStyle>
+  <p:extLst>
+    <p:ext uri="{EFAFB233-063F-42B5-8137-9DF3F51BA10A}">
+      <p15:sldGuideLst xmlns:p15="http://schemas.microsoft.com/office/powerpoint/2012/main"/>
+    </p:ext>
+  </p:extLst>
 </p:presentation>
+</file>
+
+<file path=ppt/revisionInfo.xml><?xml version="1.0" encoding="utf-8"?>
+<p1510:revInfo xmlns:a="http://schemas.openxmlformats.org/drawingml/2006/main" xmlns:r="http://schemas.openxmlformats.org/officeDocument/2006/relationships" xmlns:p1510="http://schemas.microsoft.com/office/powerpoint/2015/10/main">
+  <p1510:revLst>
+    <p1510:client id="{ED69A44D-24AC-4A36-8512-3944251D8366}" v="1" dt="2026-05-07T18:28:05.914"/>
+  </p1510:revLst>
+</p1510:revInfo>
 </file>
 
 <file path=ppt/changesInfos/changesInfo1.xml><?xml version="1.0" encoding="utf-8"?>
 <pc:chgInfo xmlns:a="http://schemas.openxmlformats.org/drawingml/2006/main" xmlns:r="http://schemas.openxmlformats.org/officeDocument/2006/relationships" xmlns:ac="http://schemas.microsoft.com/office/drawing/2013/main/command" xmlns:pc="http://schemas.microsoft.com/office/powerpoint/2013/main/command">
   <pc:docChgLst>
     <pc:chgData name="Lindeman, Mark A (US 365H)" userId="3688c61a-c847-421f-97e7-31f196fb4491" providerId="ADAL" clId="{216A9E4E-1227-49C0-8A78-42279DBF0FD8}"/>
-    <pc:docChg chg="addSld modSld">
-      <pc:chgData name="Lindeman, Mark A (US 365H)" userId="3688c61a-c847-421f-97e7-31f196fb4491" providerId="ADAL" clId="{216A9E4E-1227-49C0-8A78-42279DBF0FD8}" dt="2026-05-06T21:44:01.808" v="39" actId="20577"/>
+    <pc:docChg chg="custSel addSld modSld">
+      <pc:chgData name="Lindeman, Mark A (US 365H)" userId="3688c61a-c847-421f-97e7-31f196fb4491" providerId="ADAL" clId="{216A9E4E-1227-49C0-8A78-42279DBF0FD8}" dt="2026-05-07T18:28:19.497" v="556" actId="20577"/>
       <pc:docMkLst>
         <pc:docMk/>
       </pc:docMkLst>
@@ -163,6 +178,44 @@
           </ac:picMkLst>
         </pc:picChg>
       </pc:sldChg>
+      <pc:sldChg chg="modSp new mod">
+        <pc:chgData name="Lindeman, Mark A (US 365H)" userId="3688c61a-c847-421f-97e7-31f196fb4491" providerId="ADAL" clId="{216A9E4E-1227-49C0-8A78-42279DBF0FD8}" dt="2026-05-07T17:05:20.594" v="319" actId="20577"/>
+        <pc:sldMkLst>
+          <pc:docMk/>
+          <pc:sldMk cId="3505147043" sldId="258"/>
+        </pc:sldMkLst>
+        <pc:spChg chg="mod">
+          <ac:chgData name="Lindeman, Mark A (US 365H)" userId="3688c61a-c847-421f-97e7-31f196fb4491" providerId="ADAL" clId="{216A9E4E-1227-49C0-8A78-42279DBF0FD8}" dt="2026-05-07T17:05:20.594" v="319" actId="20577"/>
+          <ac:spMkLst>
+            <pc:docMk/>
+            <pc:sldMk cId="3505147043" sldId="258"/>
+            <ac:spMk id="3" creationId="{D05CD3A7-DA81-79D1-3E99-55FC132B84B6}"/>
+          </ac:spMkLst>
+        </pc:spChg>
+      </pc:sldChg>
+      <pc:sldChg chg="modSp new mod">
+        <pc:chgData name="Lindeman, Mark A (US 365H)" userId="3688c61a-c847-421f-97e7-31f196fb4491" providerId="ADAL" clId="{216A9E4E-1227-49C0-8A78-42279DBF0FD8}" dt="2026-05-07T18:28:19.497" v="556" actId="20577"/>
+        <pc:sldMkLst>
+          <pc:docMk/>
+          <pc:sldMk cId="1359328743" sldId="259"/>
+        </pc:sldMkLst>
+        <pc:spChg chg="mod">
+          <ac:chgData name="Lindeman, Mark A (US 365H)" userId="3688c61a-c847-421f-97e7-31f196fb4491" providerId="ADAL" clId="{216A9E4E-1227-49C0-8A78-42279DBF0FD8}" dt="2026-05-07T18:27:54.261" v="537" actId="20577"/>
+          <ac:spMkLst>
+            <pc:docMk/>
+            <pc:sldMk cId="1359328743" sldId="259"/>
+            <ac:spMk id="2" creationId="{A49531D7-6CCA-6602-E67C-83788AFF2421}"/>
+          </ac:spMkLst>
+        </pc:spChg>
+        <pc:spChg chg="mod">
+          <ac:chgData name="Lindeman, Mark A (US 365H)" userId="3688c61a-c847-421f-97e7-31f196fb4491" providerId="ADAL" clId="{216A9E4E-1227-49C0-8A78-42279DBF0FD8}" dt="2026-05-07T18:28:19.497" v="556" actId="20577"/>
+          <ac:spMkLst>
+            <pc:docMk/>
+            <pc:sldMk cId="1359328743" sldId="259"/>
+            <ac:spMk id="3" creationId="{168FD88A-8B78-5038-6CFC-8E5AEFA6E7F3}"/>
+          </ac:spMkLst>
+        </pc:spChg>
+      </pc:sldChg>
     </pc:docChg>
   </pc:docChgLst>
 </pc:chgInfo>
@@ -315,7 +368,7 @@
           <a:p>
             <a:fld id="{5634BD14-1F87-4944-B08D-D3EC23AB331F}" type="datetimeFigureOut">
               <a:rPr lang="en-US" smtClean="0"/>
-              <a:t>5/6/2026</a:t>
+              <a:t>5/7/2026</a:t>
             </a:fld>
             <a:endParaRPr lang="en-US"/>
           </a:p>
@@ -513,7 +566,7 @@
           <a:p>
             <a:fld id="{5634BD14-1F87-4944-B08D-D3EC23AB331F}" type="datetimeFigureOut">
               <a:rPr lang="en-US" smtClean="0"/>
-              <a:t>5/6/2026</a:t>
+              <a:t>5/7/2026</a:t>
             </a:fld>
             <a:endParaRPr lang="en-US"/>
           </a:p>
@@ -721,7 +774,7 @@
           <a:p>
             <a:fld id="{5634BD14-1F87-4944-B08D-D3EC23AB331F}" type="datetimeFigureOut">
               <a:rPr lang="en-US" smtClean="0"/>
-              <a:t>5/6/2026</a:t>
+              <a:t>5/7/2026</a:t>
             </a:fld>
             <a:endParaRPr lang="en-US"/>
           </a:p>
@@ -919,7 +972,7 @@
           <a:p>
             <a:fld id="{5634BD14-1F87-4944-B08D-D3EC23AB331F}" type="datetimeFigureOut">
               <a:rPr lang="en-US" smtClean="0"/>
-              <a:t>5/6/2026</a:t>
+              <a:t>5/7/2026</a:t>
             </a:fld>
             <a:endParaRPr lang="en-US"/>
           </a:p>
@@ -1194,7 +1247,7 @@
           <a:p>
             <a:fld id="{5634BD14-1F87-4944-B08D-D3EC23AB331F}" type="datetimeFigureOut">
               <a:rPr lang="en-US" smtClean="0"/>
-              <a:t>5/6/2026</a:t>
+              <a:t>5/7/2026</a:t>
             </a:fld>
             <a:endParaRPr lang="en-US"/>
           </a:p>
@@ -1459,7 +1512,7 @@
           <a:p>
             <a:fld id="{5634BD14-1F87-4944-B08D-D3EC23AB331F}" type="datetimeFigureOut">
               <a:rPr lang="en-US" smtClean="0"/>
-              <a:t>5/6/2026</a:t>
+              <a:t>5/7/2026</a:t>
             </a:fld>
             <a:endParaRPr lang="en-US"/>
           </a:p>
@@ -1871,7 +1924,7 @@
           <a:p>
             <a:fld id="{5634BD14-1F87-4944-B08D-D3EC23AB331F}" type="datetimeFigureOut">
               <a:rPr lang="en-US" smtClean="0"/>
-              <a:t>5/6/2026</a:t>
+              <a:t>5/7/2026</a:t>
             </a:fld>
             <a:endParaRPr lang="en-US"/>
           </a:p>
@@ -2012,7 +2065,7 @@
           <a:p>
             <a:fld id="{5634BD14-1F87-4944-B08D-D3EC23AB331F}" type="datetimeFigureOut">
               <a:rPr lang="en-US" smtClean="0"/>
-              <a:t>5/6/2026</a:t>
+              <a:t>5/7/2026</a:t>
             </a:fld>
             <a:endParaRPr lang="en-US"/>
           </a:p>
@@ -2125,7 +2178,7 @@
           <a:p>
             <a:fld id="{5634BD14-1F87-4944-B08D-D3EC23AB331F}" type="datetimeFigureOut">
               <a:rPr lang="en-US" smtClean="0"/>
-              <a:t>5/6/2026</a:t>
+              <a:t>5/7/2026</a:t>
             </a:fld>
             <a:endParaRPr lang="en-US"/>
           </a:p>
@@ -2436,7 +2489,7 @@
           <a:p>
             <a:fld id="{5634BD14-1F87-4944-B08D-D3EC23AB331F}" type="datetimeFigureOut">
               <a:rPr lang="en-US" smtClean="0"/>
-              <a:t>5/6/2026</a:t>
+              <a:t>5/7/2026</a:t>
             </a:fld>
             <a:endParaRPr lang="en-US"/>
           </a:p>
@@ -2724,7 +2777,7 @@
           <a:p>
             <a:fld id="{5634BD14-1F87-4944-B08D-D3EC23AB331F}" type="datetimeFigureOut">
               <a:rPr lang="en-US" smtClean="0"/>
-              <a:t>5/6/2026</a:t>
+              <a:t>5/7/2026</a:t>
             </a:fld>
             <a:endParaRPr lang="en-US"/>
           </a:p>
@@ -2965,7 +3018,7 @@
           <a:p>
             <a:fld id="{5634BD14-1F87-4944-B08D-D3EC23AB331F}" type="datetimeFigureOut">
               <a:rPr lang="en-US" smtClean="0"/>
-              <a:t>5/6/2026</a:t>
+              <a:t>5/7/2026</a:t>
             </a:fld>
             <a:endParaRPr lang="en-US"/>
           </a:p>
@@ -3562,6 +3615,257 @@
     <p:extLst>
       <p:ext uri="{BB962C8B-B14F-4D97-AF65-F5344CB8AC3E}">
         <p14:creationId xmlns:p14="http://schemas.microsoft.com/office/powerpoint/2010/main" val="412030553"/>
+      </p:ext>
+    </p:extLst>
+  </p:cSld>
+  <p:clrMapOvr>
+    <a:masterClrMapping/>
+  </p:clrMapOvr>
+</p:sld>
+</file>
+
+<file path=ppt/slides/slide3.xml><?xml version="1.0" encoding="utf-8"?>
+<p:sld xmlns:a="http://schemas.openxmlformats.org/drawingml/2006/main" xmlns:r="http://schemas.openxmlformats.org/officeDocument/2006/relationships" xmlns:p="http://schemas.openxmlformats.org/presentationml/2006/main">
+  <p:cSld>
+    <p:spTree>
+      <p:nvGrpSpPr>
+        <p:cNvPr id="1" name=""/>
+        <p:cNvGrpSpPr/>
+        <p:nvPr/>
+      </p:nvGrpSpPr>
+      <p:grpSpPr>
+        <a:xfrm>
+          <a:off x="0" y="0"/>
+          <a:ext cx="0" cy="0"/>
+          <a:chOff x="0" y="0"/>
+          <a:chExt cx="0" cy="0"/>
+        </a:xfrm>
+      </p:grpSpPr>
+      <p:sp>
+        <p:nvSpPr>
+          <p:cNvPr id="2" name="Title 1">
+            <a:extLst>
+              <a:ext uri="{FF2B5EF4-FFF2-40B4-BE49-F238E27FC236}">
+                <a16:creationId xmlns:a16="http://schemas.microsoft.com/office/drawing/2014/main" id="{BDDB2922-260C-13C9-996C-F7D1FA59BC12}"/>
+              </a:ext>
+            </a:extLst>
+          </p:cNvPr>
+          <p:cNvSpPr>
+            <a:spLocks noGrp="1"/>
+          </p:cNvSpPr>
+          <p:nvPr>
+            <p:ph type="title"/>
+          </p:nvPr>
+        </p:nvSpPr>
+        <p:spPr/>
+        <p:txBody>
+          <a:bodyPr/>
+          <a:lstStyle/>
+          <a:p>
+            <a:endParaRPr lang="en-US"/>
+          </a:p>
+        </p:txBody>
+      </p:sp>
+      <p:sp>
+        <p:nvSpPr>
+          <p:cNvPr id="3" name="Content Placeholder 2">
+            <a:extLst>
+              <a:ext uri="{FF2B5EF4-FFF2-40B4-BE49-F238E27FC236}">
+                <a16:creationId xmlns:a16="http://schemas.microsoft.com/office/drawing/2014/main" id="{D05CD3A7-DA81-79D1-3E99-55FC132B84B6}"/>
+              </a:ext>
+            </a:extLst>
+          </p:cNvPr>
+          <p:cNvSpPr>
+            <a:spLocks noGrp="1"/>
+          </p:cNvSpPr>
+          <p:nvPr>
+            <p:ph idx="1"/>
+          </p:nvPr>
+        </p:nvSpPr>
+        <p:spPr/>
+        <p:txBody>
+          <a:bodyPr/>
+          <a:lstStyle/>
+          <a:p>
+            <a:r>
+              <a:rPr lang="en-US" dirty="0"/>
+              <a:t>Copied over alpha calc</a:t>
+            </a:r>
+          </a:p>
+          <a:p>
+            <a:r>
+              <a:rPr lang="en-US" dirty="0"/>
+              <a:t>Indicates lower alpha for lower TC</a:t>
+            </a:r>
+          </a:p>
+          <a:p>
+            <a:r>
+              <a:rPr lang="en-US" dirty="0"/>
+              <a:t>Need TC &gt;3 K for alpha of 100</a:t>
+            </a:r>
+          </a:p>
+          <a:p>
+            <a:endParaRPr lang="en-US" dirty="0"/>
+          </a:p>
+          <a:p>
+            <a:r>
+              <a:rPr lang="en-US" dirty="0"/>
+              <a:t>Codex say </a:t>
+            </a:r>
+            <a:r>
+              <a:rPr lang="en-US" dirty="0" err="1"/>
+              <a:t>dfrdt</a:t>
+            </a:r>
+            <a:r>
+              <a:rPr lang="en-US" dirty="0"/>
+              <a:t> is ~ 1ppm level at low temps, with Qi are  &gt;1r6 do</a:t>
+            </a:r>
+          </a:p>
+          <a:p>
+            <a:r>
+              <a:rPr lang="en-US" dirty="0"/>
+              <a:t>So alpha - -2Qi T/ </a:t>
+            </a:r>
+            <a:r>
+              <a:rPr lang="en-US" dirty="0" err="1"/>
+              <a:t>fr</a:t>
+            </a:r>
+            <a:r>
+              <a:rPr lang="en-US" dirty="0"/>
+              <a:t> </a:t>
+            </a:r>
+            <a:r>
+              <a:rPr lang="en-US" dirty="0" err="1"/>
+              <a:t>dfr</a:t>
+            </a:r>
+            <a:r>
+              <a:rPr lang="en-US" dirty="0"/>
+              <a:t> dT = -2(1e6)(.05K)( *1e-5/K)</a:t>
+            </a:r>
+          </a:p>
+        </p:txBody>
+      </p:sp>
+    </p:spTree>
+    <p:extLst>
+      <p:ext uri="{BB962C8B-B14F-4D97-AF65-F5344CB8AC3E}">
+        <p14:creationId xmlns:p14="http://schemas.microsoft.com/office/powerpoint/2010/main" val="3505147043"/>
+      </p:ext>
+    </p:extLst>
+  </p:cSld>
+  <p:clrMapOvr>
+    <a:masterClrMapping/>
+  </p:clrMapOvr>
+</p:sld>
+</file>
+
+<file path=ppt/slides/slide4.xml><?xml version="1.0" encoding="utf-8"?>
+<p:sld xmlns:a="http://schemas.openxmlformats.org/drawingml/2006/main" xmlns:r="http://schemas.openxmlformats.org/officeDocument/2006/relationships" xmlns:p="http://schemas.openxmlformats.org/presentationml/2006/main">
+  <p:cSld>
+    <p:spTree>
+      <p:nvGrpSpPr>
+        <p:cNvPr id="1" name=""/>
+        <p:cNvGrpSpPr/>
+        <p:nvPr/>
+      </p:nvGrpSpPr>
+      <p:grpSpPr>
+        <a:xfrm>
+          <a:off x="0" y="0"/>
+          <a:ext cx="0" cy="0"/>
+          <a:chOff x="0" y="0"/>
+          <a:chExt cx="0" cy="0"/>
+        </a:xfrm>
+      </p:grpSpPr>
+      <p:sp>
+        <p:nvSpPr>
+          <p:cNvPr id="2" name="Title 1">
+            <a:extLst>
+              <a:ext uri="{FF2B5EF4-FFF2-40B4-BE49-F238E27FC236}">
+                <a16:creationId xmlns:a16="http://schemas.microsoft.com/office/drawing/2014/main" id="{A49531D7-6CCA-6602-E67C-83788AFF2421}"/>
+              </a:ext>
+            </a:extLst>
+          </p:cNvPr>
+          <p:cNvSpPr>
+            <a:spLocks noGrp="1"/>
+          </p:cNvSpPr>
+          <p:nvPr>
+            <p:ph type="title"/>
+          </p:nvPr>
+        </p:nvSpPr>
+        <p:spPr/>
+        <p:txBody>
+          <a:bodyPr/>
+          <a:lstStyle/>
+          <a:p>
+            <a:r>
+              <a:rPr lang="en-US" dirty="0"/>
+              <a:t>Looks like alpha ~150 for 3 K device at 4</a:t>
+            </a:r>
+          </a:p>
+        </p:txBody>
+      </p:sp>
+      <p:sp>
+        <p:nvSpPr>
+          <p:cNvPr id="3" name="Content Placeholder 2">
+            <a:extLst>
+              <a:ext uri="{FF2B5EF4-FFF2-40B4-BE49-F238E27FC236}">
+                <a16:creationId xmlns:a16="http://schemas.microsoft.com/office/drawing/2014/main" id="{168FD88A-8B78-5038-6CFC-8E5AEFA6E7F3}"/>
+              </a:ext>
+            </a:extLst>
+          </p:cNvPr>
+          <p:cNvSpPr>
+            <a:spLocks noGrp="1"/>
+          </p:cNvSpPr>
+          <p:nvPr>
+            <p:ph idx="1"/>
+          </p:nvPr>
+        </p:nvSpPr>
+        <p:spPr/>
+        <p:txBody>
+          <a:bodyPr/>
+          <a:lstStyle/>
+          <a:p>
+            <a:r>
+              <a:rPr lang="en-US" dirty="0"/>
+              <a:t>40 </a:t>
+            </a:r>
+            <a:r>
+              <a:rPr lang="en-US" dirty="0" err="1"/>
+              <a:t>mk</a:t>
+            </a:r>
+            <a:r>
+              <a:rPr lang="en-US" dirty="0"/>
+              <a:t>, 5% of Tc</a:t>
+            </a:r>
+          </a:p>
+          <a:p>
+            <a:r>
+              <a:rPr lang="en-US" dirty="0"/>
+              <a:t>Tc=3k would have higher sensitivity due Mattis Bardeen, alpha =140</a:t>
+            </a:r>
+          </a:p>
+          <a:p>
+            <a:r>
+              <a:rPr lang="en-US" dirty="0"/>
+              <a:t>Tc=2k </a:t>
+            </a:r>
+            <a:r>
+              <a:rPr lang="en-US"/>
+              <a:t>-&gt; alpha =100</a:t>
+            </a:r>
+            <a:endParaRPr lang="en-US" dirty="0"/>
+          </a:p>
+          <a:p>
+            <a:endParaRPr lang="en-US" dirty="0"/>
+          </a:p>
+          <a:p>
+            <a:endParaRPr lang="en-US" dirty="0"/>
+          </a:p>
+        </p:txBody>
+      </p:sp>
+    </p:spTree>
+    <p:extLst>
+      <p:ext uri="{BB962C8B-B14F-4D97-AF65-F5344CB8AC3E}">
+        <p14:creationId xmlns:p14="http://schemas.microsoft.com/office/powerpoint/2010/main" val="1359328743"/>
       </p:ext>
     </p:extLst>
   </p:cSld>

</xml_diff>